<commit_message>
Check translated figure slide layouts
</commit_message>
<xml_diff>
--- a/site-assets/sources/day3/fig-ja-en.pptx
+++ b/site-assets/sources/day3/fig-ja-en.pptx
@@ -2251,7 +2251,9 @@
           <a:bodyPr rtlCol="0" anchor="ctr"/>
           <a:lstStyle/>
           <a:p>
-            <a:pPr algn="ctr"/>
+            <a:pPr algn="ctr">
+              <a:defRPr/>
+            </a:pPr>
             <a:r>
               <a:rPr kumimoji="1" lang="en-US" altLang="ja-JP"/>
               <a:t>procss1 </a:t>
@@ -2580,13 +2582,14 @@
           </a:ln>
         </p:spPr>
         <p:txBody>
-          <a:bodyPr wrap="none" rtlCol="0">
-            <a:spAutoFit/>
-          </a:bodyPr>
-          <a:lstStyle/>
-          <a:p>
-            <a:r>
-              <a:rPr kumimoji="1" lang="ja-JP" altLang="en-US" sz="2400"/>
+          <a:bodyPr wrap="square" rtlCol="0"/>
+          <a:lstStyle/>
+          <a:p>
+            <a:pPr>
+              <a:defRPr sz="2300"/>
+            </a:pPr>
+            <a:r>
+              <a:rPr kumimoji="1" lang="ja-JP" altLang="en-US" sz="2300"/>
               <a:t>Strong scaling</a:t>
             </a:r>
           </a:p>
@@ -2622,13 +2625,14 @@
           </a:ln>
         </p:spPr>
         <p:txBody>
-          <a:bodyPr wrap="none" rtlCol="0">
-            <a:spAutoFit/>
-          </a:bodyPr>
-          <a:lstStyle/>
-          <a:p>
-            <a:r>
-              <a:rPr kumimoji="1" lang="ja-JP" altLang="en-US" sz="2400"/>
+          <a:bodyPr wrap="square" rtlCol="0"/>
+          <a:lstStyle/>
+          <a:p>
+            <a:pPr>
+              <a:defRPr sz="2300"/>
+            </a:pPr>
+            <a:r>
+              <a:rPr kumimoji="1" lang="ja-JP" altLang="en-US" sz="2300"/>
               <a:t>Weak scaling</a:t>
             </a:r>
           </a:p>
@@ -2755,11 +2759,14 @@
           <a:noFill/>
         </p:spPr>
         <p:txBody>
-          <a:bodyPr wrap="none" rtlCol="0">
-            <a:spAutoFit/>
+          <a:bodyPr wrap="square" rtlCol="0">
+            <a:normAutofit/>
           </a:bodyPr>
           <a:lstStyle/>
           <a:p>
+            <a:pPr>
+              <a:defRPr/>
+            </a:pPr>
             <a:r>
               <a:rPr kumimoji="1" lang="ja-JP" altLang="en-US"/>
               <a:t>Keep the total amount of computation fixed, increase parallelism, and reduce execution time</a:t>
@@ -2790,13 +2797,14 @@
           <a:noFill/>
         </p:spPr>
         <p:txBody>
-          <a:bodyPr wrap="none" rtlCol="0">
-            <a:spAutoFit/>
-          </a:bodyPr>
-          <a:lstStyle/>
-          <a:p>
-            <a:r>
-              <a:rPr kumimoji="1" lang="ja-JP" altLang="en-US"/>
+          <a:bodyPr wrap="square" rtlCol="0"/>
+          <a:lstStyle/>
+          <a:p>
+            <a:pPr>
+              <a:defRPr sz="1300"/>
+            </a:pPr>
+            <a:r>
+              <a:rPr kumimoji="1" lang="ja-JP" altLang="en-US" sz="1300"/>
               <a:t>Keep computation per parallel unit fixed, increase parallelism, and increase the total size</a:t>
             </a:r>
           </a:p>
@@ -3158,6 +3166,9 @@
           </a:bodyPr>
           <a:lstStyle/>
           <a:p>
+            <a:pPr>
+              <a:defRPr/>
+            </a:pPr>
             <a:r>
               <a:rPr kumimoji="1" lang="ja-JP" altLang="en-US" sz="1100"/>
               <a:t>Process 1</a:t>
@@ -3194,6 +3205,9 @@
           </a:bodyPr>
           <a:lstStyle/>
           <a:p>
+            <a:pPr>
+              <a:defRPr/>
+            </a:pPr>
             <a:r>
               <a:rPr kumimoji="1" lang="ja-JP" altLang="en-US" sz="1100"/>
               <a:t>Process 2</a:t>
@@ -3230,6 +3244,9 @@
           </a:bodyPr>
           <a:lstStyle/>
           <a:p>
+            <a:pPr>
+              <a:defRPr/>
+            </a:pPr>
             <a:r>
               <a:rPr kumimoji="1" lang="ja-JP" altLang="en-US" sz="1100"/>
               <a:t>Process 3</a:t>
@@ -3266,6 +3283,9 @@
           </a:bodyPr>
           <a:lstStyle/>
           <a:p>
+            <a:pPr>
+              <a:defRPr/>
+            </a:pPr>
             <a:r>
               <a:rPr kumimoji="1" lang="ja-JP" altLang="en-US" sz="1100"/>
               <a:t>Process 4</a:t>
@@ -3302,6 +3322,9 @@
           </a:bodyPr>
           <a:lstStyle/>
           <a:p>
+            <a:pPr>
+              <a:defRPr/>
+            </a:pPr>
             <a:r>
               <a:rPr kumimoji="1" lang="ja-JP" altLang="en-US" sz="1100"/>
               <a:t>Process 1</a:t>
@@ -3338,6 +3361,9 @@
           </a:bodyPr>
           <a:lstStyle/>
           <a:p>
+            <a:pPr>
+              <a:defRPr/>
+            </a:pPr>
             <a:r>
               <a:rPr kumimoji="1" lang="ja-JP" altLang="en-US" sz="1100"/>
               <a:t>Process 2</a:t>
@@ -3374,6 +3400,9 @@
           </a:bodyPr>
           <a:lstStyle/>
           <a:p>
+            <a:pPr>
+              <a:defRPr/>
+            </a:pPr>
             <a:r>
               <a:rPr kumimoji="1" lang="ja-JP" altLang="en-US" sz="1100"/>
               <a:t>Process 3</a:t>
@@ -3410,6 +3439,9 @@
           </a:bodyPr>
           <a:lstStyle/>
           <a:p>
+            <a:pPr>
+              <a:defRPr/>
+            </a:pPr>
             <a:r>
               <a:rPr kumimoji="1" lang="ja-JP" altLang="en-US" sz="1100"/>
               <a:t>Process 4</a:t>

</xml_diff>